<commit_message>
Replace speed superlatives with factual specs
Removes 'fastest on Earth' / 'fastest academic supercomputer' / 'most
powerful' claims from the slides, notebook, and site. Describes Frontera
by its published specs instead: 8,368 nodes, 56 cores and 192 GB per node,
468,608 cores total.
</commit_message>
<xml_diff>
--- a/slides/pfx-hpc-slides.pptx
+++ b/slides/pfx-hpc-slides.pptx
@@ -687,7 +687,7 @@
           <a:p>
             <a:r>
               <a:rPr lang="en-US" dirty="0"/>
-              <a:t>The emotional core of the talk. Slow down here. The point is belonging: this powerful thing is for them too.</a:t>
+              <a:t>The emotional core of the talk. Slow down here. The point is access and belonging, not speed records.</a:t>
             </a:r>
             <a:endParaRPr lang="en-US" dirty="0"/>
           </a:p>
@@ -775,7 +775,7 @@
           <a:p>
             <a:r>
               <a:rPr lang="en-US" dirty="0"/>
-              <a:t>Let the numbers land. The last line is the comparison that makes it real for a 17-year-old.</a:t>
+              <a:t>Stick to the specs. The comparison to their own laptop is what makes the scale land, not a ranking.</a:t>
             </a:r>
             <a:endParaRPr lang="en-US" dirty="0"/>
           </a:p>
@@ -1832,7 +1832,7 @@
                 <a:ea typeface="Calibri" pitchFamily="34" charset="-122"/>
                 <a:cs typeface="Calibri" pitchFamily="34" charset="-120"/>
               </a:rPr>
-              <a:t>Writing real code that runs on Frontera, one of the fastest computers on Earth.</a:t>
+              <a:t>Writing real code that runs on Frontera, a research supercomputer at TACC.</a:t>
             </a:r>
             <a:endParaRPr lang="en-US" sz="2000" dirty="0"/>
           </a:p>
@@ -2006,7 +2006,7 @@
                 <a:ea typeface="Calibri" pitchFamily="34" charset="-122"/>
                 <a:cs typeface="Calibri" pitchFamily="34" charset="-120"/>
               </a:rPr>
-              <a:t>What you're about to do, running code across many cores on Frontera, is exactly what computational scientists do every day. You belong in that room.</a:t>
+              <a:t>What you're about to do, running code across many cores on Frontera, is the same kind of work computational scientists do. You belong in that room.</a:t>
             </a:r>
             <a:endParaRPr lang="en-US" sz="2000" dirty="0"/>
           </a:p>
@@ -2119,7 +2119,7 @@
                 <a:ea typeface="Arial" pitchFamily="34" charset="-122"/>
                 <a:cs typeface="Arial" pitchFamily="34" charset="-120"/>
               </a:rPr>
-              <a:t>Right now, you're about to log into one of the fastest computers on Earth.</a:t>
+              <a:t>Today you get time on a research supercomputer.</a:t>
             </a:r>
             <a:endParaRPr lang="en-US" sz="4000" dirty="0"/>
           </a:p>
@@ -2158,7 +2158,7 @@
                 <a:ea typeface="Calibri" pitchFamily="34" charset="-122"/>
                 <a:cs typeface="Calibri" pitchFamily="34" charset="-120"/>
               </a:rPr>
-              <a:t>Not a lab down the hall. A national research supercomputer in Austin, Texas, that scientists compete for time on. Today, you get to use it.</a:t>
+              <a:t>Frontera is a shared research system at the Texas Advanced Computing Center in Austin, Texas. Researchers apply for time on it. This morning, it's yours.</a:t>
             </a:r>
             <a:endParaRPr lang="en-US" sz="1900" dirty="0"/>
           </a:p>
@@ -2307,7 +2307,7 @@
                 <a:ea typeface="Arial" pitchFamily="34" charset="-122"/>
                 <a:cs typeface="Arial" pitchFamily="34" charset="-120"/>
               </a:rPr>
-              <a:t>A machine built for problems too big for any laptop</a:t>
+              <a:t>Frontera by the numbers</a:t>
             </a:r>
             <a:endParaRPr lang="en-US" sz="3200" dirty="0"/>
           </a:p>
@@ -2474,7 +2474,7 @@
                 <a:ea typeface="Arial" pitchFamily="34" charset="-122"/>
                 <a:cs typeface="Arial" pitchFamily="34" charset="-120"/>
               </a:rPr>
-              <a:t>468,000</a:t>
+              <a:t>56</a:t>
             </a:r>
             <a:endParaRPr lang="en-US" sz="4600" dirty="0"/>
           </a:p>
@@ -2513,7 +2513,7 @@
                 <a:ea typeface="Calibri" pitchFamily="34" charset="-122"/>
                 <a:cs typeface="Calibri" pitchFamily="34" charset="-120"/>
               </a:rPr>
-              <a:t>processor cores</a:t>
+              <a:t>cores per node</a:t>
             </a:r>
             <a:endParaRPr lang="en-US" sz="1500" dirty="0"/>
           </a:p>
@@ -2577,7 +2577,7 @@
                 <a:ea typeface="Arial" pitchFamily="34" charset="-122"/>
                 <a:cs typeface="Arial" pitchFamily="34" charset="-120"/>
               </a:rPr>
-              <a:t>#1</a:t>
+              <a:t>468,608</a:t>
             </a:r>
             <a:endParaRPr lang="en-US" sz="4600" dirty="0"/>
           </a:p>
@@ -2616,7 +2616,7 @@
                 <a:ea typeface="Calibri" pitchFamily="34" charset="-122"/>
                 <a:cs typeface="Calibri" pitchFamily="34" charset="-120"/>
               </a:rPr>
-              <a:t>fastest U.S. academic</a:t>
+              <a:t>processor cores</a:t>
             </a:r>
             <a:endParaRPr lang="en-US" sz="1500" dirty="0"/>
           </a:p>
@@ -2633,7 +2633,7 @@
                 <a:ea typeface="Calibri" pitchFamily="34" charset="-122"/>
                 <a:cs typeface="Calibri" pitchFamily="34" charset="-120"/>
               </a:rPr>
-              <a:t>supercomputer at launch</a:t>
+              <a:t>in total</a:t>
             </a:r>
             <a:endParaRPr lang="en-US" sz="1500" dirty="0"/>
           </a:p>
@@ -2697,7 +2697,7 @@
                 <a:ea typeface="Arial" pitchFamily="34" charset="-122"/>
                 <a:cs typeface="Arial" pitchFamily="34" charset="-120"/>
               </a:rPr>
-              <a:t>NSF</a:t>
+              <a:t>192 GB</a:t>
             </a:r>
             <a:endParaRPr lang="en-US" sz="4600" dirty="0"/>
           </a:p>
@@ -2736,63 +2736,46 @@
                 <a:ea typeface="Calibri" pitchFamily="34" charset="-122"/>
                 <a:cs typeface="Calibri" pitchFamily="34" charset="-120"/>
               </a:rPr>
-              <a:t>funded, for open</a:t>
+              <a:t>memory per node</a:t>
             </a:r>
             <a:endParaRPr lang="en-US" sz="1500" dirty="0"/>
           </a:p>
-          <a:p>
-            <a:pPr algn="ctr" indent="0" marL="0">
-              <a:buNone/>
-            </a:pPr>
-            <a:r>
-              <a:rPr lang="en-US" sz="1500" dirty="0">
-                <a:solidFill>
-                  <a:srgbClr val="1A1A1A"/>
+        </p:txBody>
+      </p:sp>
+      <p:sp>
+        <p:nvSpPr>
+          <p:cNvPr id="16" name="Text 14"/>
+          <p:cNvSpPr/>
+          <p:nvPr/>
+        </p:nvSpPr>
+        <p:spPr>
+          <a:xfrm>
+            <a:off x="640080" y="5257800"/>
+            <a:ext cx="10972800" cy="457200"/>
+          </a:xfrm>
+          <a:prstGeom prst="rect">
+            <a:avLst/>
+          </a:prstGeom>
+          <a:noFill/>
+          <a:ln/>
+        </p:spPr>
+        <p:txBody>
+          <a:bodyPr wrap="square" lIns="0" tIns="0" rIns="0" bIns="0" rtlCol="0" anchor="ctr"/>
+          <a:lstStyle/>
+          <a:p>
+            <a:pPr indent="0" marL="0">
+              <a:buNone/>
+            </a:pPr>
+            <a:r>
+              <a:rPr lang="en-US" sz="1800" i="1" dirty="0">
+                <a:solidFill>
+                  <a:srgbClr val="6E6E70"/>
                 </a:solidFill>
                 <a:latin typeface="Calibri" pitchFamily="34" charset="0"/>
                 <a:ea typeface="Calibri" pitchFamily="34" charset="-122"/>
                 <a:cs typeface="Calibri" pitchFamily="34" charset="-120"/>
               </a:rPr>
-              <a:t>scientific research</a:t>
-            </a:r>
-            <a:endParaRPr lang="en-US" sz="1500" dirty="0"/>
-          </a:p>
-        </p:txBody>
-      </p:sp>
-      <p:sp>
-        <p:nvSpPr>
-          <p:cNvPr id="16" name="Text 14"/>
-          <p:cNvSpPr/>
-          <p:nvPr/>
-        </p:nvSpPr>
-        <p:spPr>
-          <a:xfrm>
-            <a:off x="640080" y="5257800"/>
-            <a:ext cx="10972800" cy="457200"/>
-          </a:xfrm>
-          <a:prstGeom prst="rect">
-            <a:avLst/>
-          </a:prstGeom>
-          <a:noFill/>
-          <a:ln/>
-        </p:spPr>
-        <p:txBody>
-          <a:bodyPr wrap="square" lIns="0" tIns="0" rIns="0" bIns="0" rtlCol="0" anchor="ctr"/>
-          <a:lstStyle/>
-          <a:p>
-            <a:pPr indent="0" marL="0">
-              <a:buNone/>
-            </a:pPr>
-            <a:r>
-              <a:rPr lang="en-US" sz="1800" i="1" dirty="0">
-                <a:solidFill>
-                  <a:srgbClr val="6E6E70"/>
-                </a:solidFill>
-                <a:latin typeface="Calibri" pitchFamily="34" charset="0"/>
-                <a:ea typeface="Calibri" pitchFamily="34" charset="-122"/>
-                <a:cs typeface="Calibri" pitchFamily="34" charset="-120"/>
-              </a:rPr>
-              <a:t>Your laptop has maybe 4 to 10 cores. Frontera has almost half a million.</a:t>
+              <a:t>Your laptop has roughly 4 to 10 cores. One Frontera node has 56, and there are 8,368 nodes.</a:t>
             </a:r>
             <a:endParaRPr lang="en-US" sz="1800" dirty="0"/>
           </a:p>
@@ -3044,7 +3027,7 @@
                 <a:ea typeface="Arial" pitchFamily="34" charset="-122"/>
                 <a:cs typeface="Arial" pitchFamily="34" charset="-120"/>
               </a:rPr>
-              <a:t>Predicting hurricanes</a:t>
+              <a:t>Hurricanes and weather</a:t>
             </a:r>
             <a:endParaRPr lang="en-US" sz="2000" dirty="0"/>
           </a:p>
@@ -3083,7 +3066,7 @@
                 <a:ea typeface="Calibri" pitchFamily="34" charset="-122"/>
                 <a:cs typeface="Calibri" pitchFamily="34" charset="-120"/>
               </a:rPr>
-              <a:t>Storm-surge and forecast models that help coastal cities decide when to evacuate.</a:t>
+              <a:t>Storm-surge and weather models that simulate how hurricanes form and move.</a:t>
             </a:r>
             <a:endParaRPr lang="en-US" sz="1500" dirty="0"/>
           </a:p>

</xml_diff>

<commit_message>
Swap Part 3 to photo editing + epidemic sweep; drop laptop comparison
Replaces the prime-counting demo with two domain examples that run 1 core
vs all 56 on Frontera: batch photo filtering (media) and an SIR epidemic
parameter sweep (public health), both timed and visualized. Removes the
password/brute-force example.

Also removes all laptop-vs-Frontera comparisons from the notebook, site,
and slide 3, presenting Frontera purely by its own scale (one node, 250
reserved nodes, 8,368 total), since a single node does not beat a modern
high-end laptop on speed. Requires numpy + matplotlib in the TAP kernel.
</commit_message>
<xml_diff>
--- a/slides/pfx-hpc-slides.pptx
+++ b/slides/pfx-hpc-slides.pptx
@@ -775,7 +775,7 @@
           <a:p>
             <a:r>
               <a:rPr lang="en-US" dirty="0"/>
-              <a:t>Stick to the specs. The comparison to their own laptop is what makes the scale land, not a ranking.</a:t>
+              <a:t>Stick to the specs, and lead with scale: one node, thousands of nodes, 250 reserved for this room. No laptop comparison.</a:t>
             </a:r>
             <a:endParaRPr lang="en-US" dirty="0"/>
           </a:p>
@@ -2775,7 +2775,7 @@
                 <a:ea typeface="Calibri" pitchFamily="34" charset="-122"/>
                 <a:cs typeface="Calibri" pitchFamily="34" charset="-120"/>
               </a:rPr>
-              <a:t>Your laptop has roughly 4 to 10 cores. One Frontera node has 56, and there are 8,368 nodes.</a:t>
+              <a:t>One node has 56 cores. Frontera has 8,368 of them, and 250 are reserved just for this workshop.</a:t>
             </a:r>
             <a:endParaRPr lang="en-US" sz="1800" dirty="0"/>
           </a:p>

</xml_diff>

<commit_message>
Retitle opening slide to match agenda
Title slide now reads 'Unlocking What's Possible Through Data &
High-Performance Computing' to match the session agenda, with a subtitle
noting it's a hands-on Python hour on Frontera.
</commit_message>
<xml_diff>
--- a/slides/pfx-hpc-slides.pptx
+++ b/slides/pfx-hpc-slides.pptx
@@ -1745,8 +1745,8 @@
         </p:nvSpPr>
         <p:spPr>
           <a:xfrm>
-            <a:off x="640080" y="2103120"/>
-            <a:ext cx="10515600" cy="2377440"/>
+            <a:off x="640080" y="1508760"/>
+            <a:ext cx="10972800" cy="3108960"/>
           </a:xfrm>
           <a:prstGeom prst="rect">
             <a:avLst/>
@@ -1760,12 +1760,12 @@
           <a:p>
             <a:pPr indent="0" marL="0">
               <a:lnSpc>
-                <a:spcPts val="6200"/>
+                <a:spcPts val="4600"/>
               </a:lnSpc>
               <a:buNone/>
             </a:pPr>
             <a:r>
-              <a:rPr lang="en-US" sz="6000" b="1" dirty="0">
+              <a:rPr lang="en-US" sz="4000" b="1" dirty="0">
                 <a:solidFill>
                   <a:srgbClr val="FFFFFF"/>
                 </a:solidFill>
@@ -1773,19 +1773,19 @@
                 <a:ea typeface="Arial" pitchFamily="34" charset="-122"/>
                 <a:cs typeface="Arial" pitchFamily="34" charset="-120"/>
               </a:rPr>
-              <a:t>Intro to Python</a:t>
-            </a:r>
-            <a:endParaRPr lang="en-US" sz="6000" dirty="0"/>
+              <a:t>Unlocking What's Possible</a:t>
+            </a:r>
+            <a:endParaRPr lang="en-US" sz="4000" dirty="0"/>
           </a:p>
           <a:p>
             <a:pPr indent="0" marL="0">
               <a:lnSpc>
-                <a:spcPts val="6200"/>
+                <a:spcPts val="4600"/>
               </a:lnSpc>
               <a:buNone/>
             </a:pPr>
             <a:r>
-              <a:rPr lang="en-US" sz="6000" b="1" dirty="0">
+              <a:rPr lang="en-US" sz="4000" b="1" dirty="0">
                 <a:solidFill>
                   <a:srgbClr val="FFFFFF"/>
                 </a:solidFill>
@@ -1793,9 +1793,29 @@
                 <a:ea typeface="Arial" pitchFamily="34" charset="-122"/>
                 <a:cs typeface="Arial" pitchFamily="34" charset="-120"/>
               </a:rPr>
-              <a:t>&amp; Supercomputing</a:t>
-            </a:r>
-            <a:endParaRPr lang="en-US" sz="6000" dirty="0"/>
+              <a:t>Through Data &amp;</a:t>
+            </a:r>
+            <a:endParaRPr lang="en-US" sz="4000" dirty="0"/>
+          </a:p>
+          <a:p>
+            <a:pPr indent="0" marL="0">
+              <a:lnSpc>
+                <a:spcPts val="4600"/>
+              </a:lnSpc>
+              <a:buNone/>
+            </a:pPr>
+            <a:r>
+              <a:rPr lang="en-US" sz="4000" b="1" dirty="0">
+                <a:solidFill>
+                  <a:srgbClr val="FFFFFF"/>
+                </a:solidFill>
+                <a:latin typeface="Arial" pitchFamily="34" charset="0"/>
+                <a:ea typeface="Arial" pitchFamily="34" charset="-122"/>
+                <a:cs typeface="Arial" pitchFamily="34" charset="-120"/>
+              </a:rPr>
+              <a:t>High-Performance Computing</a:t>
+            </a:r>
+            <a:endParaRPr lang="en-US" sz="4000" dirty="0"/>
           </a:p>
         </p:txBody>
       </p:sp>
@@ -1807,8 +1827,8 @@
         </p:nvSpPr>
         <p:spPr>
           <a:xfrm>
-            <a:off x="640080" y="4526280"/>
-            <a:ext cx="9601200" cy="548640"/>
+            <a:off x="640080" y="4800600"/>
+            <a:ext cx="10058400" cy="548640"/>
           </a:xfrm>
           <a:prstGeom prst="rect">
             <a:avLst/>
@@ -1832,7 +1852,7 @@
                 <a:ea typeface="Calibri" pitchFamily="34" charset="-122"/>
                 <a:cs typeface="Calibri" pitchFamily="34" charset="-120"/>
               </a:rPr>
-              <a:t>Writing real code that runs on Frontera, a research supercomputer at TACC.</a:t>
+              <a:t>A hands-on hour writing Python on Frontera, a research supercomputer at TACC.</a:t>
             </a:r>
             <a:endParaRPr lang="en-US" sz="2000" dirty="0"/>
           </a:p>

</xml_diff>

<commit_message>
Revise deck: future-tense reservation, fix alignment, trim roadmap, add systems wrap
- Slide 6: reservation is future tense (we have one, so no queue wait); drop 'Morehouse' name from the card.
- Slide 8: center 'Many cores' label and caption over the dot grid.
- Slide 9: remove the code line (nobody has run code yet); reframe Python as the on-ramp that scales to HPC.
- Slide 10: drop the 'learn core Python' step; three exploration steps, not a coding syllabus.
- Remove the ground-rules slide.
- Add two closing slides: a Frontera/Stampede3/Vista comparison (Morehouse allocation gives access to all three) and a sign-off. Deck is now 14 slides.
</commit_message>
<xml_diff>
--- a/slides/pfx-hpc-slides.pptx
+++ b/slides/pfx-hpc-slides.pptx
@@ -18,9 +18,10 @@
     <p:sldId id="266" r:id="rId12"/>
     <p:sldId id="267" r:id="rId13"/>
     <p:sldId id="268" r:id="rId14"/>
+    <p:sldId id="269" r:id="rId15"/>
   </p:sldIdLst>
   <p:notesMasterIdLst>
-    <p:notesMasterId r:id="rId15"/>
+    <p:notesMasterId r:id="rId16"/>
   </p:notesMasterIdLst>
   <p:sldSz cx="12191695" cy="6858000"/>
   <p:notesSz cx="6858000" cy="12191695"/>
@@ -778,7 +779,7 @@
           <a:p>
             <a:r>
               <a:rPr lang="en-US" dirty="0"/>
-              <a:t>Lower the stakes. The biggest blocker for beginners is fear of breaking something. Say explicitly: you can't.</a:t>
+              <a:t>Land the belonging message, then switch to the browser and open TAP together. This is the transition into the notebook.</a:t>
             </a:r>
             <a:endParaRPr lang="en-US" dirty="0"/>
           </a:p>
@@ -866,7 +867,7 @@
           <a:p>
             <a:r>
               <a:rPr lang="en-US" dirty="0"/>
-              <a:t>Land the belonging message, then switch to the browser and open TAP together. This is the transition into the notebook.</a:t>
+              <a:t>We used Frontera because I expected about 250 people and needed to reserve at least 250 nodes; Frontera has the capacity for a group that size. But you're not limited to it. Reach for Vista when your work needs GPUs, that's the AI and machine-learning machine. Stampede3 is a strong general-purpose CPU system.</a:t>
             </a:r>
             <a:endParaRPr lang="en-US" dirty="0"/>
           </a:p>
@@ -890,6 +891,94 @@
             <a:fld id="{F7021451-1387-4CA6-816F-3879F97B5CBC}" type="slidenum">
               <a:rPr lang="en-US"/>
               <a:t>13</a:t>
+            </a:fld>
+            <a:endParaRPr lang="en-US"/>
+          </a:p>
+        </p:txBody>
+      </p:sp>
+    </p:spTree>
+    <p:extLst>
+      <p:ext uri="{BB962C8B-B14F-4D97-AF65-F5344CB8AC3E}">
+        <p14:creationId xmlns:p14="http://schemas.microsoft.com/office/powerpoint/2010/main" val="1024086991"/>
+      </p:ext>
+    </p:extLst>
+  </p:cSld>
+  <p:clrMapOvr>
+    <a:masterClrMapping/>
+  </p:clrMapOvr>
+</p:notes>
+</file>
+
+<file path=ppt/notesSlides/notesSlide14.xml><?xml version="1.0" encoding="utf-8"?>
+<p:notes xmlns:a="http://schemas.openxmlformats.org/drawingml/2006/main" xmlns:r="http://schemas.openxmlformats.org/officeDocument/2006/relationships" xmlns:p="http://schemas.openxmlformats.org/presentationml/2006/main">
+  <p:cSld>
+    <p:spTree>
+      <p:nvGrpSpPr>
+        <p:cNvPr id="1" name=""/>
+        <p:cNvGrpSpPr/>
+        <p:nvPr/>
+      </p:nvGrpSpPr>
+      <p:grpSpPr>
+        <a:xfrm>
+          <a:off x="0" y="0"/>
+          <a:ext cx="0" cy="0"/>
+          <a:chOff x="0" y="0"/>
+          <a:chExt cx="0" cy="0"/>
+        </a:xfrm>
+      </p:grpSpPr>
+      <p:sp>
+        <p:nvSpPr>
+          <p:cNvPr id="2" name="Slide Image Placeholder 1"/>
+          <p:cNvSpPr>
+            <a:spLocks noGrp="1" noRot="1" noChangeAspect="1"/>
+          </p:cNvSpPr>
+          <p:nvPr>
+            <p:ph type="sldImg"/>
+          </p:nvPr>
+        </p:nvSpPr>
+        <p:spPr/>
+      </p:sp>
+      <p:sp>
+        <p:nvSpPr>
+          <p:cNvPr id="3" name="Notes Placeholder 2"/>
+          <p:cNvSpPr>
+            <a:spLocks noGrp="1"/>
+          </p:cNvSpPr>
+          <p:nvPr>
+            <p:ph type="body" idx="1"/>
+          </p:nvPr>
+        </p:nvSpPr>
+        <p:spPr/>
+        <p:txBody>
+          <a:bodyPr/>
+          <a:lstStyle/>
+          <a:p>
+            <a:r>
+              <a:rPr lang="en-US" dirty="0"/>
+              <a:t>Close it out. They now have real access to three national systems.</a:t>
+            </a:r>
+            <a:endParaRPr lang="en-US" dirty="0"/>
+          </a:p>
+        </p:txBody>
+      </p:sp>
+      <p:sp>
+        <p:nvSpPr>
+          <p:cNvPr id="4" name="Slide Number Placeholder 3"/>
+          <p:cNvSpPr>
+            <a:spLocks noGrp="1"/>
+          </p:cNvSpPr>
+          <p:nvPr>
+            <p:ph type="sldNum" sz="quarter" idx="10"/>
+          </p:nvPr>
+        </p:nvSpPr>
+        <p:spPr/>
+        <p:txBody>
+          <a:bodyPr/>
+          <a:lstStyle/>
+          <a:p>
+            <a:fld id="{F7021451-1387-4CA6-816F-3879F97B5CBC}" type="slidenum">
+              <a:rPr lang="en-US"/>
+              <a:t>14</a:t>
             </a:fld>
             <a:endParaRPr lang="en-US"/>
           </a:p>
@@ -1570,7 +1659,7 @@
           <a:p>
             <a:r>
               <a:rPr lang="en-US" dirty="0"/>
-              <a:t>End on the code line: that's the first thing they'll actually run. Say it out loud as a promise, not a warning.</a:t>
+              <a:t>The point isn't to teach Python today. It's that Python is the on-ramp: the same language scales all the way up to a supercomputer.</a:t>
             </a:r>
             <a:endParaRPr lang="en-US" dirty="0"/>
           </a:p>
@@ -2282,7 +2371,7 @@
         </p:nvSpPr>
         <p:spPr>
           <a:xfrm>
-            <a:off x="640080" y="2286000"/>
+            <a:off x="640080" y="2560320"/>
             <a:ext cx="640080" cy="640080"/>
           </a:xfrm>
           <a:prstGeom prst="ellipse">
@@ -2307,7 +2396,7 @@
         </p:nvSpPr>
         <p:spPr>
           <a:xfrm>
-            <a:off x="640080" y="2286000"/>
+            <a:off x="640080" y="2560320"/>
             <a:ext cx="640080" cy="640080"/>
           </a:xfrm>
           <a:prstGeom prst="rect">
@@ -2346,7 +2435,7 @@
         </p:nvSpPr>
         <p:spPr>
           <a:xfrm>
-            <a:off x="1554480" y="2267712"/>
+            <a:off x="1554480" y="2542032"/>
             <a:ext cx="4754880" cy="640080"/>
           </a:xfrm>
           <a:prstGeom prst="rect">
@@ -2371,7 +2460,7 @@
                 <a:ea typeface="Arial" pitchFamily="34" charset="-122"/>
                 <a:cs typeface="Arial" pitchFamily="34" charset="-120"/>
               </a:rPr>
-              <a:t>Prove where you are</a:t>
+              <a:t>See where you are</a:t>
             </a:r>
             <a:endParaRPr lang="en-US" sz="2100" dirty="0"/>
           </a:p>
@@ -2385,7 +2474,7 @@
         </p:nvSpPr>
         <p:spPr>
           <a:xfrm>
-            <a:off x="6675120" y="2286000"/>
+            <a:off x="6675120" y="2560320"/>
             <a:ext cx="4846320" cy="640080"/>
           </a:xfrm>
           <a:prstGeom prst="rect">
@@ -2410,7 +2499,7 @@
                 <a:ea typeface="Calibri" pitchFamily="34" charset="-122"/>
                 <a:cs typeface="Calibri" pitchFamily="34" charset="-120"/>
               </a:rPr>
-              <a:t>Run a line of code and see the supercomputer answer back.</a:t>
+              <a:t>Run a cell and watch the supercomputer answer back.</a:t>
             </a:r>
             <a:endParaRPr lang="en-US" sz="1600" dirty="0"/>
           </a:p>
@@ -2424,7 +2513,7 @@
         </p:nvSpPr>
         <p:spPr>
           <a:xfrm>
-            <a:off x="640080" y="3337560"/>
+            <a:off x="640080" y="3794760"/>
             <a:ext cx="640080" cy="640080"/>
           </a:xfrm>
           <a:prstGeom prst="ellipse">
@@ -2449,7 +2538,7 @@
         </p:nvSpPr>
         <p:spPr>
           <a:xfrm>
-            <a:off x="640080" y="3337560"/>
+            <a:off x="640080" y="3794760"/>
             <a:ext cx="640080" cy="640080"/>
           </a:xfrm>
           <a:prstGeom prst="rect">
@@ -2488,7 +2577,7 @@
         </p:nvSpPr>
         <p:spPr>
           <a:xfrm>
-            <a:off x="1554480" y="3319272"/>
+            <a:off x="1554480" y="3776472"/>
             <a:ext cx="4754880" cy="640080"/>
           </a:xfrm>
           <a:prstGeom prst="rect">
@@ -2513,7 +2602,7 @@
                 <a:ea typeface="Arial" pitchFamily="34" charset="-122"/>
                 <a:cs typeface="Arial" pitchFamily="34" charset="-120"/>
               </a:rPr>
-              <a:t>Learn core Python</a:t>
+              <a:t>Put many cores to work</a:t>
             </a:r>
             <a:endParaRPr lang="en-US" sz="2100" dirty="0"/>
           </a:p>
@@ -2527,7 +2616,7 @@
         </p:nvSpPr>
         <p:spPr>
           <a:xfrm>
-            <a:off x="6675120" y="3337560"/>
+            <a:off x="6675120" y="3794760"/>
             <a:ext cx="4846320" cy="640080"/>
           </a:xfrm>
           <a:prstGeom prst="rect">
@@ -2552,7 +2641,7 @@
                 <a:ea typeface="Calibri" pitchFamily="34" charset="-122"/>
                 <a:cs typeface="Calibri" pitchFamily="34" charset="-120"/>
               </a:rPr>
-              <a:t>Variables, math, text, lists, loops, decisions, and functions.</a:t>
+              <a:t>Analyze data and run models the slow way, then across all 56 cores.</a:t>
             </a:r>
             <a:endParaRPr lang="en-US" sz="1600" dirty="0"/>
           </a:p>
@@ -2566,7 +2655,7 @@
         </p:nvSpPr>
         <p:spPr>
           <a:xfrm>
-            <a:off x="640080" y="4389120"/>
+            <a:off x="640080" y="5029200"/>
             <a:ext cx="640080" cy="640080"/>
           </a:xfrm>
           <a:prstGeom prst="ellipse">
@@ -2591,7 +2680,7 @@
         </p:nvSpPr>
         <p:spPr>
           <a:xfrm>
-            <a:off x="640080" y="4389120"/>
+            <a:off x="640080" y="5029200"/>
             <a:ext cx="640080" cy="640080"/>
           </a:xfrm>
           <a:prstGeom prst="rect">
@@ -2630,7 +2719,7 @@
         </p:nvSpPr>
         <p:spPr>
           <a:xfrm>
-            <a:off x="1554480" y="4370832"/>
+            <a:off x="1554480" y="5010912"/>
             <a:ext cx="4754880" cy="640080"/>
           </a:xfrm>
           <a:prstGeom prst="rect">
@@ -2655,7 +2744,7 @@
                 <a:ea typeface="Arial" pitchFamily="34" charset="-122"/>
                 <a:cs typeface="Arial" pitchFamily="34" charset="-120"/>
               </a:rPr>
-              <a:t>Use many cores at once</a:t>
+              <a:t>Meet the ideas of HPC</a:t>
             </a:r>
             <a:endParaRPr lang="en-US" sz="2100" dirty="0"/>
           </a:p>
@@ -2669,7 +2758,7 @@
         </p:nvSpPr>
         <p:spPr>
           <a:xfrm>
-            <a:off x="6675120" y="4389120"/>
+            <a:off x="6675120" y="5029200"/>
             <a:ext cx="4846320" cy="640080"/>
           </a:xfrm>
           <a:prstGeom prst="rect">
@@ -2694,7 +2783,7 @@
                 <a:ea typeface="Calibri" pitchFamily="34" charset="-122"/>
                 <a:cs typeface="Calibri" pitchFamily="34" charset="-120"/>
               </a:rPr>
-              <a:t>Run a task the slow way, then the fast way, and time the difference.</a:t>
+              <a:t>Nodes, jobs, and the scale that makes it powerful.</a:t>
             </a:r>
             <a:endParaRPr lang="en-US" sz="1600" dirty="0"/>
           </a:p>
@@ -2702,149 +2791,7 @@
       </p:sp>
       <p:sp>
         <p:nvSpPr>
-          <p:cNvPr id="16" name="Shape 14"/>
-          <p:cNvSpPr/>
-          <p:nvPr/>
-        </p:nvSpPr>
-        <p:spPr>
-          <a:xfrm>
-            <a:off x="640080" y="5440680"/>
-            <a:ext cx="640080" cy="640080"/>
-          </a:xfrm>
-          <a:prstGeom prst="ellipse">
-            <a:avLst/>
-          </a:prstGeom>
-          <a:solidFill>
-            <a:srgbClr val="C1A231"/>
-          </a:solidFill>
-          <a:ln w="12700">
-            <a:solidFill>
-              <a:srgbClr val="C1A231"/>
-            </a:solidFill>
-            <a:prstDash val="solid"/>
-          </a:ln>
-        </p:spPr>
-      </p:sp>
-      <p:sp>
-        <p:nvSpPr>
-          <p:cNvPr id="17" name="Text 15"/>
-          <p:cNvSpPr/>
-          <p:nvPr/>
-        </p:nvSpPr>
-        <p:spPr>
-          <a:xfrm>
-            <a:off x="640080" y="5440680"/>
-            <a:ext cx="640080" cy="640080"/>
-          </a:xfrm>
-          <a:prstGeom prst="rect">
-            <a:avLst/>
-          </a:prstGeom>
-          <a:noFill/>
-          <a:ln/>
-        </p:spPr>
-        <p:txBody>
-          <a:bodyPr wrap="square" lIns="0" tIns="0" rIns="0" bIns="0" rtlCol="0" anchor="ctr"/>
-          <a:lstStyle/>
-          <a:p>
-            <a:pPr algn="ctr" indent="0" marL="0">
-              <a:buNone/>
-            </a:pPr>
-            <a:r>
-              <a:rPr lang="en-US" sz="2600" b="1" dirty="0">
-                <a:solidFill>
-                  <a:srgbClr val="840028"/>
-                </a:solidFill>
-                <a:latin typeface="Arial" pitchFamily="34" charset="0"/>
-                <a:ea typeface="Arial" pitchFamily="34" charset="-122"/>
-                <a:cs typeface="Arial" pitchFamily="34" charset="-120"/>
-              </a:rPr>
-              <a:t>4</a:t>
-            </a:r>
-            <a:endParaRPr lang="en-US" sz="2600" dirty="0"/>
-          </a:p>
-        </p:txBody>
-      </p:sp>
-      <p:sp>
-        <p:nvSpPr>
-          <p:cNvPr id="18" name="Text 16"/>
-          <p:cNvSpPr/>
-          <p:nvPr/>
-        </p:nvSpPr>
-        <p:spPr>
-          <a:xfrm>
-            <a:off x="1554480" y="5422392"/>
-            <a:ext cx="4754880" cy="640080"/>
-          </a:xfrm>
-          <a:prstGeom prst="rect">
-            <a:avLst/>
-          </a:prstGeom>
-          <a:noFill/>
-          <a:ln/>
-        </p:spPr>
-        <p:txBody>
-          <a:bodyPr wrap="square" lIns="0" tIns="0" rIns="0" bIns="0" rtlCol="0" anchor="ctr"/>
-          <a:lstStyle/>
-          <a:p>
-            <a:pPr indent="0" marL="0">
-              <a:buNone/>
-            </a:pPr>
-            <a:r>
-              <a:rPr lang="en-US" sz="2100" b="1" dirty="0">
-                <a:solidFill>
-                  <a:srgbClr val="1A1A1A"/>
-                </a:solidFill>
-                <a:latin typeface="Arial" pitchFamily="34" charset="0"/>
-                <a:ea typeface="Arial" pitchFamily="34" charset="-122"/>
-                <a:cs typeface="Arial" pitchFamily="34" charset="-120"/>
-              </a:rPr>
-              <a:t>Meet the ideas of HPC</a:t>
-            </a:r>
-            <a:endParaRPr lang="en-US" sz="2100" dirty="0"/>
-          </a:p>
-        </p:txBody>
-      </p:sp>
-      <p:sp>
-        <p:nvSpPr>
-          <p:cNvPr id="19" name="Text 17"/>
-          <p:cNvSpPr/>
-          <p:nvPr/>
-        </p:nvSpPr>
-        <p:spPr>
-          <a:xfrm>
-            <a:off x="6675120" y="5440680"/>
-            <a:ext cx="4846320" cy="640080"/>
-          </a:xfrm>
-          <a:prstGeom prst="rect">
-            <a:avLst/>
-          </a:prstGeom>
-          <a:noFill/>
-          <a:ln/>
-        </p:spPr>
-        <p:txBody>
-          <a:bodyPr wrap="square" lIns="0" tIns="0" rIns="0" bIns="0" rtlCol="0" anchor="ctr"/>
-          <a:lstStyle/>
-          <a:p>
-            <a:pPr indent="0" marL="0">
-              <a:buNone/>
-            </a:pPr>
-            <a:r>
-              <a:rPr lang="en-US" sz="1600" dirty="0">
-                <a:solidFill>
-                  <a:srgbClr val="6E6E70"/>
-                </a:solidFill>
-                <a:latin typeface="Calibri" pitchFamily="34" charset="0"/>
-                <a:ea typeface="Calibri" pitchFamily="34" charset="-122"/>
-                <a:cs typeface="Calibri" pitchFamily="34" charset="-120"/>
-              </a:rPr>
-              <a:t>Nodes, files, and how big jobs get scheduled.</a:t>
-            </a:r>
-            <a:endParaRPr lang="en-US" sz="1600" dirty="0"/>
-          </a:p>
-        </p:txBody>
-      </p:sp>
-      <p:sp>
-        <p:nvSpPr>
-          <p:cNvPr id="20" name="Text 18"/>
+          <p:cNvPr id="16" name="Text 14"/>
           <p:cNvSpPr/>
           <p:nvPr/>
         </p:nvSpPr>
@@ -3187,6 +3134,180 @@
     <p:bg>
       <p:bgPr>
         <a:solidFill>
+          <a:srgbClr val="840028"/>
+        </a:solidFill>
+      </p:bgPr>
+    </p:bg>
+    <p:spTree>
+      <p:nvGrpSpPr>
+        <p:cNvPr id="1" name=""/>
+        <p:cNvGrpSpPr/>
+        <p:nvPr/>
+      </p:nvGrpSpPr>
+      <p:grpSpPr>
+        <a:xfrm>
+          <a:off x="0" y="0"/>
+          <a:ext cx="0" cy="0"/>
+          <a:chOff x="0" y="0"/>
+          <a:chExt cx="0" cy="0"/>
+        </a:xfrm>
+      </p:grpSpPr>
+      <p:sp>
+        <p:nvSpPr>
+          <p:cNvPr id="2" name="Shape 0"/>
+          <p:cNvSpPr/>
+          <p:nvPr/>
+        </p:nvSpPr>
+        <p:spPr>
+          <a:xfrm>
+            <a:off x="640080" y="640080"/>
+            <a:ext cx="502920" cy="502920"/>
+          </a:xfrm>
+          <a:prstGeom prst="ellipse">
+            <a:avLst/>
+          </a:prstGeom>
+          <a:ln w="38100">
+            <a:solidFill>
+              <a:srgbClr val="C1A231"/>
+            </a:solidFill>
+            <a:prstDash val="solid"/>
+          </a:ln>
+        </p:spPr>
+      </p:sp>
+      <p:sp>
+        <p:nvSpPr>
+          <p:cNvPr id="3" name="Text 1"/>
+          <p:cNvSpPr/>
+          <p:nvPr/>
+        </p:nvSpPr>
+        <p:spPr>
+          <a:xfrm>
+            <a:off x="640080" y="2011680"/>
+            <a:ext cx="10972800" cy="1645920"/>
+          </a:xfrm>
+          <a:prstGeom prst="rect">
+            <a:avLst/>
+          </a:prstGeom>
+          <a:noFill/>
+          <a:ln/>
+        </p:spPr>
+        <p:txBody>
+          <a:bodyPr wrap="square" lIns="0" tIns="0" rIns="0" bIns="0" rtlCol="0" anchor="ctr"/>
+          <a:lstStyle/>
+          <a:p>
+            <a:pPr indent="0" marL="0">
+              <a:lnSpc>
+                <a:spcPts val="5000"/>
+              </a:lnSpc>
+              <a:buNone/>
+            </a:pPr>
+            <a:r>
+              <a:rPr lang="en-US" sz="4400" b="1" dirty="0">
+                <a:solidFill>
+                  <a:srgbClr val="FFFFFF"/>
+                </a:solidFill>
+                <a:latin typeface="Arial" pitchFamily="34" charset="0"/>
+                <a:ea typeface="Arial" pitchFamily="34" charset="-122"/>
+                <a:cs typeface="Arial" pitchFamily="34" charset="-120"/>
+              </a:rPr>
+              <a:t>Let's get you on the supercomputer.</a:t>
+            </a:r>
+            <a:endParaRPr lang="en-US" sz="4400" dirty="0"/>
+          </a:p>
+        </p:txBody>
+      </p:sp>
+      <p:sp>
+        <p:nvSpPr>
+          <p:cNvPr id="4" name="Text 2"/>
+          <p:cNvSpPr/>
+          <p:nvPr/>
+        </p:nvSpPr>
+        <p:spPr>
+          <a:xfrm>
+            <a:off x="640080" y="3749040"/>
+            <a:ext cx="10515600" cy="1188720"/>
+          </a:xfrm>
+          <a:prstGeom prst="rect">
+            <a:avLst/>
+          </a:prstGeom>
+          <a:noFill/>
+          <a:ln/>
+        </p:spPr>
+        <p:txBody>
+          <a:bodyPr wrap="square" lIns="0" tIns="0" rIns="0" bIns="0" rtlCol="0" anchor="ctr"/>
+          <a:lstStyle/>
+          <a:p>
+            <a:pPr indent="0" marL="0">
+              <a:buNone/>
+            </a:pPr>
+            <a:r>
+              <a:rPr lang="en-US" sz="2000" i="1" dirty="0">
+                <a:solidFill>
+                  <a:srgbClr val="C1A231"/>
+                </a:solidFill>
+                <a:latin typeface="Calibri" pitchFamily="34" charset="0"/>
+                <a:ea typeface="Calibri" pitchFamily="34" charset="-122"/>
+                <a:cs typeface="Calibri" pitchFamily="34" charset="-120"/>
+              </a:rPr>
+              <a:t>What you're about to do, running code across many cores on Frontera, is the same kind of work computational scientists do. You belong in that room.</a:t>
+            </a:r>
+            <a:endParaRPr lang="en-US" sz="2000" dirty="0"/>
+          </a:p>
+        </p:txBody>
+      </p:sp>
+      <p:sp>
+        <p:nvSpPr>
+          <p:cNvPr id="5" name="Text 3"/>
+          <p:cNvSpPr/>
+          <p:nvPr/>
+        </p:nvSpPr>
+        <p:spPr>
+          <a:xfrm>
+            <a:off x="640080" y="5943600"/>
+            <a:ext cx="10972800" cy="365760"/>
+          </a:xfrm>
+          <a:prstGeom prst="rect">
+            <a:avLst/>
+          </a:prstGeom>
+          <a:noFill/>
+          <a:ln/>
+        </p:spPr>
+        <p:txBody>
+          <a:bodyPr wrap="square" lIns="0" tIns="0" rIns="0" bIns="0" rtlCol="0" anchor="ctr"/>
+          <a:lstStyle/>
+          <a:p>
+            <a:pPr indent="0" marL="0">
+              <a:buNone/>
+            </a:pPr>
+            <a:r>
+              <a:rPr lang="en-US" sz="1500" dirty="0">
+                <a:solidFill>
+                  <a:srgbClr val="E9D9DE"/>
+                </a:solidFill>
+                <a:latin typeface="Calibri" pitchFamily="34" charset="0"/>
+                <a:ea typeface="Calibri" pitchFamily="34" charset="-122"/>
+                <a:cs typeface="Calibri" pitchFamily="34" charset="-120"/>
+              </a:rPr>
+              <a:t>Setup, notebook, and slides:  ashleyscruse.github.io/pfx-hpc</a:t>
+            </a:r>
+            <a:endParaRPr lang="en-US" sz="1500" dirty="0"/>
+          </a:p>
+        </p:txBody>
+      </p:sp>
+    </p:spTree>
+  </p:cSld>
+  <p:clrMapOvr>
+    <a:masterClrMapping/>
+  </p:clrMapOvr>
+</p:sld>
+</file>
+
+<file path=ppt/slides/slide13.xml><?xml version="1.0" encoding="utf-8"?>
+<p:sld xmlns:a="http://schemas.openxmlformats.org/drawingml/2006/main" xmlns:r="http://schemas.openxmlformats.org/officeDocument/2006/relationships" xmlns:p="http://schemas.openxmlformats.org/presentationml/2006/main">
+  <p:cSld name="Slide 13">
+    <p:bg>
+      <p:bgPr>
+        <a:solidFill>
           <a:srgbClr val="FFFFFF"/>
         </a:solidFill>
       </p:bgPr>
@@ -3238,7 +3359,7 @@
                 <a:ea typeface="Arial" pitchFamily="34" charset="-122"/>
                 <a:cs typeface="Arial" pitchFamily="34" charset="-120"/>
               </a:rPr>
-              <a:t>GROUND RULES</a:t>
+              <a:t>WHAT'S NEXT</a:t>
             </a:r>
             <a:endParaRPr lang="en-US" sz="1300" dirty="0"/>
           </a:p>
@@ -3277,7 +3398,7 @@
                 <a:ea typeface="Arial" pitchFamily="34" charset="-122"/>
                 <a:cs typeface="Arial" pitchFamily="34" charset="-120"/>
               </a:rPr>
-              <a:t>Running the notebook</a:t>
+              <a:t>You have more than Frontera</a:t>
             </a:r>
             <a:endParaRPr lang="en-US" sz="3200" dirty="0"/>
           </a:p>
@@ -3285,41 +3406,78 @@
       </p:sp>
       <p:sp>
         <p:nvSpPr>
-          <p:cNvPr id="4" name="Shape 2"/>
-          <p:cNvSpPr/>
-          <p:nvPr/>
-        </p:nvSpPr>
-        <p:spPr>
-          <a:xfrm>
-            <a:off x="640080" y="2286000"/>
-            <a:ext cx="4754880" cy="1463040"/>
-          </a:xfrm>
-          <a:prstGeom prst="roundRect">
-            <a:avLst>
-              <a:gd name="adj" fmla="val 7500"/>
-            </a:avLst>
+          <p:cNvPr id="4" name="Text 2"/>
+          <p:cNvSpPr/>
+          <p:nvPr/>
+        </p:nvSpPr>
+        <p:spPr>
+          <a:xfrm>
+            <a:off x="640080" y="1645920"/>
+            <a:ext cx="10972800" cy="548640"/>
+          </a:xfrm>
+          <a:prstGeom prst="rect">
+            <a:avLst/>
+          </a:prstGeom>
+          <a:noFill/>
+          <a:ln/>
+        </p:spPr>
+        <p:txBody>
+          <a:bodyPr wrap="square" lIns="0" tIns="0" rIns="0" bIns="0" rtlCol="0" anchor="ctr"/>
+          <a:lstStyle/>
+          <a:p>
+            <a:pPr indent="0" marL="0">
+              <a:buNone/>
+            </a:pPr>
+            <a:r>
+              <a:rPr lang="en-US" sz="1600" dirty="0">
+                <a:solidFill>
+                  <a:srgbClr val="6E6E70"/>
+                </a:solidFill>
+                <a:latin typeface="Calibri" pitchFamily="34" charset="0"/>
+                <a:ea typeface="Calibri" pitchFamily="34" charset="-122"/>
+                <a:cs typeface="Calibri" pitchFamily="34" charset="-120"/>
+              </a:rPr>
+              <a:t>Joining the Morehouse allocation gives you three TACC supercomputers with one login. Different machines are built for different jobs.</a:t>
+            </a:r>
+            <a:endParaRPr lang="en-US" sz="1600" dirty="0"/>
+          </a:p>
+        </p:txBody>
+      </p:sp>
+      <p:sp>
+        <p:nvSpPr>
+          <p:cNvPr id="5" name="Shape 3"/>
+          <p:cNvSpPr/>
+          <p:nvPr/>
+        </p:nvSpPr>
+        <p:spPr>
+          <a:xfrm>
+            <a:off x="640080" y="2377440"/>
+            <a:ext cx="3611880" cy="3246120"/>
+          </a:xfrm>
+          <a:prstGeom prst="rect">
+            <a:avLst/>
           </a:prstGeom>
           <a:solidFill>
             <a:srgbClr val="EFEDEA"/>
           </a:solidFill>
-          <a:ln w="19050">
-            <a:solidFill>
-              <a:srgbClr val="840028"/>
-            </a:solidFill>
-            <a:prstDash val="solid"/>
-          </a:ln>
-        </p:spPr>
-      </p:sp>
-      <p:sp>
-        <p:nvSpPr>
-          <p:cNvPr id="5" name="Text 3"/>
-          <p:cNvSpPr/>
-          <p:nvPr/>
-        </p:nvSpPr>
-        <p:spPr>
-          <a:xfrm>
-            <a:off x="640080" y="2286000"/>
-            <a:ext cx="4754880" cy="1463040"/>
+          <a:ln w="12700">
+            <a:solidFill>
+              <a:srgbClr val="EFEDEA"/>
+            </a:solidFill>
+            <a:prstDash val="solid"/>
+          </a:ln>
+        </p:spPr>
+      </p:sp>
+      <p:sp>
+        <p:nvSpPr>
+          <p:cNvPr id="6" name="Text 4"/>
+          <p:cNvSpPr/>
+          <p:nvPr/>
+        </p:nvSpPr>
+        <p:spPr>
+          <a:xfrm>
+            <a:off x="868680" y="2560320"/>
+            <a:ext cx="3154680" cy="457200"/>
           </a:xfrm>
           <a:prstGeom prst="rect">
             <a:avLst/>
@@ -3331,11 +3489,11 @@
           <a:bodyPr wrap="square" lIns="0" tIns="0" rIns="0" bIns="0" rtlCol="0" anchor="ctr"/>
           <a:lstStyle/>
           <a:p>
-            <a:pPr algn="ctr" indent="0" marL="0">
-              <a:buNone/>
-            </a:pPr>
-            <a:r>
-              <a:rPr lang="en-US" sz="3400" b="1" dirty="0">
+            <a:pPr indent="0" marL="0">
+              <a:buNone/>
+            </a:pPr>
+            <a:r>
+              <a:rPr lang="en-US" sz="2200" b="1" dirty="0">
                 <a:solidFill>
                   <a:srgbClr val="840028"/>
                 </a:solidFill>
@@ -3343,81 +3501,55 @@
                 <a:ea typeface="Arial" pitchFamily="34" charset="-122"/>
                 <a:cs typeface="Arial" pitchFamily="34" charset="-120"/>
               </a:rPr>
-              <a:t>Shift + Enter</a:t>
-            </a:r>
-            <a:endParaRPr lang="en-US" sz="3400" dirty="0"/>
-          </a:p>
-        </p:txBody>
-      </p:sp>
-      <p:sp>
-        <p:nvSpPr>
-          <p:cNvPr id="6" name="Text 4"/>
-          <p:cNvSpPr/>
-          <p:nvPr/>
-        </p:nvSpPr>
-        <p:spPr>
-          <a:xfrm>
-            <a:off x="640080" y="3840480"/>
-            <a:ext cx="4754880" cy="457200"/>
-          </a:xfrm>
-          <a:prstGeom prst="rect">
-            <a:avLst/>
-          </a:prstGeom>
-          <a:noFill/>
-          <a:ln/>
-        </p:spPr>
-        <p:txBody>
-          <a:bodyPr wrap="square" lIns="0" tIns="0" rIns="0" bIns="0" rtlCol="0" anchor="ctr"/>
-          <a:lstStyle/>
-          <a:p>
-            <a:pPr algn="ctr" indent="0" marL="0">
-              <a:buNone/>
-            </a:pPr>
-            <a:r>
-              <a:rPr lang="en-US" sz="1600" dirty="0">
-                <a:solidFill>
-                  <a:srgbClr val="6E6E70"/>
+              <a:t>Frontera</a:t>
+            </a:r>
+            <a:endParaRPr lang="en-US" sz="2200" dirty="0"/>
+          </a:p>
+        </p:txBody>
+      </p:sp>
+      <p:sp>
+        <p:nvSpPr>
+          <p:cNvPr id="7" name="Text 5"/>
+          <p:cNvSpPr/>
+          <p:nvPr/>
+        </p:nvSpPr>
+        <p:spPr>
+          <a:xfrm>
+            <a:off x="868680" y="3127248"/>
+            <a:ext cx="3154680" cy="868680"/>
+          </a:xfrm>
+          <a:prstGeom prst="rect">
+            <a:avLst/>
+          </a:prstGeom>
+          <a:noFill/>
+          <a:ln/>
+        </p:spPr>
+        <p:txBody>
+          <a:bodyPr wrap="square" lIns="0" tIns="0" rIns="0" bIns="0" rtlCol="0" anchor="t"/>
+          <a:lstStyle/>
+          <a:p>
+            <a:pPr indent="0" marL="0">
+              <a:buNone/>
+            </a:pPr>
+            <a:r>
+              <a:rPr lang="en-US" sz="1450" dirty="0">
+                <a:solidFill>
+                  <a:srgbClr val="1A1A1A"/>
                 </a:solidFill>
                 <a:latin typeface="Calibri" pitchFamily="34" charset="0"/>
                 <a:ea typeface="Calibri" pitchFamily="34" charset="-122"/>
                 <a:cs typeface="Calibri" pitchFamily="34" charset="-120"/>
               </a:rPr>
-              <a:t>runs the cell you're in</a:t>
-            </a:r>
-            <a:endParaRPr lang="en-US" sz="1600" dirty="0"/>
-          </a:p>
-        </p:txBody>
-      </p:sp>
-      <p:sp>
-        <p:nvSpPr>
-          <p:cNvPr id="7" name="Text 5"/>
-          <p:cNvSpPr/>
-          <p:nvPr/>
-        </p:nvSpPr>
-        <p:spPr>
-          <a:xfrm>
-            <a:off x="5852160" y="2286000"/>
-            <a:ext cx="5669280" cy="2377440"/>
-          </a:xfrm>
-          <a:prstGeom prst="rect">
-            <a:avLst/>
-          </a:prstGeom>
-          <a:noFill/>
-          <a:ln/>
-        </p:spPr>
-        <p:txBody>
-          <a:bodyPr wrap="square" lIns="0" tIns="0" rIns="0" bIns="0" rtlCol="0" anchor="ctr"/>
-          <a:lstStyle/>
-          <a:p>
-            <a:pPr marL="342900" indent="-342900">
-              <a:spcAft>
-                <a:spcPts val="1000"/>
-              </a:spcAft>
-              <a:buSzPct val="100000"/>
-              <a:buChar char="•"/>
-            </a:pPr>
-            <a:r>
-              <a:rPr lang="en-US" sz="1800" dirty="0">
+              <a:t>8,368 CPU nodes</a:t>
+            </a:r>
+            <a:endParaRPr lang="en-US" sz="1450" dirty="0"/>
+          </a:p>
+          <a:p>
+            <a:pPr indent="0" marL="0">
+              <a:buNone/>
+            </a:pPr>
+            <a:r>
+              <a:rPr lang="en-US" sz="1450" dirty="0">
                 <a:solidFill>
                   <a:srgbClr val="1A1A1A"/>
                 </a:solidFill>
@@ -3425,20 +3557,77 @@
                 <a:ea typeface="Calibri" pitchFamily="34" charset="-122"/>
                 <a:cs typeface="Calibri" pitchFamily="34" charset="-120"/>
               </a:rPr>
-              <a:t>Run the cells in order, top to bottom.</a:t>
-            </a:r>
-            <a:endParaRPr lang="en-US" sz="1800" dirty="0"/>
-          </a:p>
-          <a:p>
-            <a:pPr marL="342900" indent="-342900">
-              <a:spcAft>
-                <a:spcPts val="1000"/>
-              </a:spcAft>
-              <a:buSzPct val="100000"/>
-              <a:buChar char="•"/>
-            </a:pPr>
-            <a:r>
-              <a:rPr lang="en-US" sz="1800" dirty="0">
+              <a:t>56 cores each</a:t>
+            </a:r>
+            <a:endParaRPr lang="en-US" sz="1450" dirty="0"/>
+          </a:p>
+        </p:txBody>
+      </p:sp>
+      <p:sp>
+        <p:nvSpPr>
+          <p:cNvPr id="8" name="Text 6"/>
+          <p:cNvSpPr/>
+          <p:nvPr/>
+        </p:nvSpPr>
+        <p:spPr>
+          <a:xfrm>
+            <a:off x="868680" y="4114800"/>
+            <a:ext cx="3154680" cy="274320"/>
+          </a:xfrm>
+          <a:prstGeom prst="rect">
+            <a:avLst/>
+          </a:prstGeom>
+          <a:noFill/>
+          <a:ln/>
+        </p:spPr>
+        <p:txBody>
+          <a:bodyPr wrap="square" lIns="0" tIns="0" rIns="0" bIns="0" rtlCol="0" anchor="ctr"/>
+          <a:lstStyle/>
+          <a:p>
+            <a:pPr indent="0" marL="0">
+              <a:buNone/>
+            </a:pPr>
+            <a:r>
+              <a:rPr lang="en-US" sz="1200" b="1" spc="200" kern="0" dirty="0">
+                <a:solidFill>
+                  <a:srgbClr val="840028"/>
+                </a:solidFill>
+                <a:latin typeface="Arial" pitchFamily="34" charset="0"/>
+                <a:ea typeface="Arial" pitchFamily="34" charset="-122"/>
+                <a:cs typeface="Arial" pitchFamily="34" charset="-120"/>
+              </a:rPr>
+              <a:t>BEST FOR</a:t>
+            </a:r>
+            <a:endParaRPr lang="en-US" sz="1200" dirty="0"/>
+          </a:p>
+        </p:txBody>
+      </p:sp>
+      <p:sp>
+        <p:nvSpPr>
+          <p:cNvPr id="9" name="Text 7"/>
+          <p:cNvSpPr/>
+          <p:nvPr/>
+        </p:nvSpPr>
+        <p:spPr>
+          <a:xfrm>
+            <a:off x="868680" y="4407408"/>
+            <a:ext cx="3154680" cy="1051560"/>
+          </a:xfrm>
+          <a:prstGeom prst="rect">
+            <a:avLst/>
+          </a:prstGeom>
+          <a:noFill/>
+          <a:ln/>
+        </p:spPr>
+        <p:txBody>
+          <a:bodyPr wrap="square" lIns="0" tIns="0" rIns="0" bIns="0" rtlCol="0" anchor="t"/>
+          <a:lstStyle/>
+          <a:p>
+            <a:pPr indent="0" marL="0">
+              <a:buNone/>
+            </a:pPr>
+            <a:r>
+              <a:rPr lang="en-US" sz="1400" dirty="0">
                 <a:solidFill>
                   <a:srgbClr val="1A1A1A"/>
                 </a:solidFill>
@@ -3446,20 +3635,102 @@
                 <a:ea typeface="Calibri" pitchFamily="34" charset="-122"/>
                 <a:cs typeface="Calibri" pitchFamily="34" charset="-120"/>
               </a:rPr>
-              <a:t>Change the values. Make them yours.</a:t>
-            </a:r>
-            <a:endParaRPr lang="en-US" sz="1800" dirty="0"/>
-          </a:p>
-          <a:p>
-            <a:pPr marL="342900" indent="-342900">
-              <a:spcAft>
-                <a:spcPts val="1000"/>
-              </a:spcAft>
-              <a:buSzPct val="100000"/>
-              <a:buChar char="•"/>
-            </a:pPr>
-            <a:r>
-              <a:rPr lang="en-US" sz="1800" dirty="0">
+              <a:t>Very large CPU jobs and big groups. It's why we used it today.</a:t>
+            </a:r>
+            <a:endParaRPr lang="en-US" sz="1400" dirty="0"/>
+          </a:p>
+        </p:txBody>
+      </p:sp>
+      <p:sp>
+        <p:nvSpPr>
+          <p:cNvPr id="10" name="Shape 8"/>
+          <p:cNvSpPr/>
+          <p:nvPr/>
+        </p:nvSpPr>
+        <p:spPr>
+          <a:xfrm>
+            <a:off x="4480560" y="2377440"/>
+            <a:ext cx="3611880" cy="3246120"/>
+          </a:xfrm>
+          <a:prstGeom prst="rect">
+            <a:avLst/>
+          </a:prstGeom>
+          <a:solidFill>
+            <a:srgbClr val="EFEDEA"/>
+          </a:solidFill>
+          <a:ln w="12700">
+            <a:solidFill>
+              <a:srgbClr val="EFEDEA"/>
+            </a:solidFill>
+            <a:prstDash val="solid"/>
+          </a:ln>
+        </p:spPr>
+      </p:sp>
+      <p:sp>
+        <p:nvSpPr>
+          <p:cNvPr id="11" name="Text 9"/>
+          <p:cNvSpPr/>
+          <p:nvPr/>
+        </p:nvSpPr>
+        <p:spPr>
+          <a:xfrm>
+            <a:off x="4709160" y="2560320"/>
+            <a:ext cx="3154680" cy="457200"/>
+          </a:xfrm>
+          <a:prstGeom prst="rect">
+            <a:avLst/>
+          </a:prstGeom>
+          <a:noFill/>
+          <a:ln/>
+        </p:spPr>
+        <p:txBody>
+          <a:bodyPr wrap="square" lIns="0" tIns="0" rIns="0" bIns="0" rtlCol="0" anchor="ctr"/>
+          <a:lstStyle/>
+          <a:p>
+            <a:pPr indent="0" marL="0">
+              <a:buNone/>
+            </a:pPr>
+            <a:r>
+              <a:rPr lang="en-US" sz="2200" b="1" dirty="0">
+                <a:solidFill>
+                  <a:srgbClr val="840028"/>
+                </a:solidFill>
+                <a:latin typeface="Arial" pitchFamily="34" charset="0"/>
+                <a:ea typeface="Arial" pitchFamily="34" charset="-122"/>
+                <a:cs typeface="Arial" pitchFamily="34" charset="-120"/>
+              </a:rPr>
+              <a:t>Stampede3</a:t>
+            </a:r>
+            <a:endParaRPr lang="en-US" sz="2200" dirty="0"/>
+          </a:p>
+        </p:txBody>
+      </p:sp>
+      <p:sp>
+        <p:nvSpPr>
+          <p:cNvPr id="12" name="Text 10"/>
+          <p:cNvSpPr/>
+          <p:nvPr/>
+        </p:nvSpPr>
+        <p:spPr>
+          <a:xfrm>
+            <a:off x="4709160" y="3127248"/>
+            <a:ext cx="3154680" cy="868680"/>
+          </a:xfrm>
+          <a:prstGeom prst="rect">
+            <a:avLst/>
+          </a:prstGeom>
+          <a:noFill/>
+          <a:ln/>
+        </p:spPr>
+        <p:txBody>
+          <a:bodyPr wrap="square" lIns="0" tIns="0" rIns="0" bIns="0" rtlCol="0" anchor="t"/>
+          <a:lstStyle/>
+          <a:p>
+            <a:pPr indent="0" marL="0">
+              <a:buNone/>
+            </a:pPr>
+            <a:r>
+              <a:rPr lang="en-US" sz="1450" dirty="0">
                 <a:solidFill>
                   <a:srgbClr val="1A1A1A"/>
                 </a:solidFill>
@@ -3467,20 +3738,16 @@
                 <a:ea typeface="Calibri" pitchFamily="34" charset="-122"/>
                 <a:cs typeface="Calibri" pitchFamily="34" charset="-120"/>
               </a:rPr>
-              <a:t>If something breaks, just re-run it. Nothing you do can harm the computer.</a:t>
-            </a:r>
-            <a:endParaRPr lang="en-US" sz="1800" dirty="0"/>
-          </a:p>
-          <a:p>
-            <a:pPr marL="342900" indent="-342900">
-              <a:spcAft>
-                <a:spcPts val="1000"/>
-              </a:spcAft>
-              <a:buSzPct val="100000"/>
-              <a:buChar char="•"/>
-            </a:pPr>
-            <a:r>
-              <a:rPr lang="en-US" sz="1800" dirty="0">
+              <a:t>~1,900 nodes</a:t>
+            </a:r>
+            <a:endParaRPr lang="en-US" sz="1450" dirty="0"/>
+          </a:p>
+          <a:p>
+            <a:pPr indent="0" marL="0">
+              <a:buNone/>
+            </a:pPr>
+            <a:r>
+              <a:rPr lang="en-US" sz="1450" dirty="0">
                 <a:solidFill>
                   <a:srgbClr val="1A1A1A"/>
                 </a:solidFill>
@@ -3488,22 +3755,22 @@
                 <a:ea typeface="Calibri" pitchFamily="34" charset="-122"/>
                 <a:cs typeface="Calibri" pitchFamily="34" charset="-120"/>
               </a:rPr>
-              <a:t>Ask questions the moment you're stuck.</a:t>
-            </a:r>
-            <a:endParaRPr lang="en-US" sz="1800" dirty="0"/>
-          </a:p>
-        </p:txBody>
-      </p:sp>
-      <p:sp>
-        <p:nvSpPr>
-          <p:cNvPr id="8" name="Text 6"/>
-          <p:cNvSpPr/>
-          <p:nvPr/>
-        </p:nvSpPr>
-        <p:spPr>
-          <a:xfrm>
-            <a:off x="640080" y="5120640"/>
-            <a:ext cx="10972800" cy="548640"/>
+              <a:t>Intel CPUs + some GPUs</a:t>
+            </a:r>
+            <a:endParaRPr lang="en-US" sz="1450" dirty="0"/>
+          </a:p>
+        </p:txBody>
+      </p:sp>
+      <p:sp>
+        <p:nvSpPr>
+          <p:cNvPr id="13" name="Text 11"/>
+          <p:cNvSpPr/>
+          <p:nvPr/>
+        </p:nvSpPr>
+        <p:spPr>
+          <a:xfrm>
+            <a:off x="4709160" y="4114800"/>
+            <a:ext cx="3154680" cy="274320"/>
           </a:xfrm>
           <a:prstGeom prst="rect">
             <a:avLst/>
@@ -3519,30 +3786,94 @@
               <a:buNone/>
             </a:pPr>
             <a:r>
-              <a:rPr lang="en-US" sz="1800" i="1" dirty="0">
+              <a:rPr lang="en-US" sz="1200" b="1" spc="200" kern="0" dirty="0">
                 <a:solidFill>
                   <a:srgbClr val="840028"/>
+                </a:solidFill>
+                <a:latin typeface="Arial" pitchFamily="34" charset="0"/>
+                <a:ea typeface="Arial" pitchFamily="34" charset="-122"/>
+                <a:cs typeface="Arial" pitchFamily="34" charset="-120"/>
+              </a:rPr>
+              <a:t>BEST FOR</a:t>
+            </a:r>
+            <a:endParaRPr lang="en-US" sz="1200" dirty="0"/>
+          </a:p>
+        </p:txBody>
+      </p:sp>
+      <p:sp>
+        <p:nvSpPr>
+          <p:cNvPr id="14" name="Text 12"/>
+          <p:cNvSpPr/>
+          <p:nvPr/>
+        </p:nvSpPr>
+        <p:spPr>
+          <a:xfrm>
+            <a:off x="4709160" y="4407408"/>
+            <a:ext cx="3154680" cy="1051560"/>
+          </a:xfrm>
+          <a:prstGeom prst="rect">
+            <a:avLst/>
+          </a:prstGeom>
+          <a:noFill/>
+          <a:ln/>
+        </p:spPr>
+        <p:txBody>
+          <a:bodyPr wrap="square" lIns="0" tIns="0" rIns="0" bIns="0" rtlCol="0" anchor="t"/>
+          <a:lstStyle/>
+          <a:p>
+            <a:pPr indent="0" marL="0">
+              <a:buNone/>
+            </a:pPr>
+            <a:r>
+              <a:rPr lang="en-US" sz="1400" dirty="0">
+                <a:solidFill>
+                  <a:srgbClr val="1A1A1A"/>
                 </a:solidFill>
                 <a:latin typeface="Calibri" pitchFamily="34" charset="0"/>
                 <a:ea typeface="Calibri" pitchFamily="34" charset="-122"/>
                 <a:cs typeface="Calibri" pitchFamily="34" charset="-120"/>
               </a:rPr>
-              <a:t>Breaking things and fixing them is how you learn to code.</a:t>
-            </a:r>
-            <a:endParaRPr lang="en-US" sz="1800" dirty="0"/>
-          </a:p>
-        </p:txBody>
-      </p:sp>
-      <p:sp>
-        <p:nvSpPr>
-          <p:cNvPr id="9" name="Text 7"/>
-          <p:cNvSpPr/>
-          <p:nvPr/>
-        </p:nvSpPr>
-        <p:spPr>
-          <a:xfrm>
-            <a:off x="11185855" y="6217920"/>
-            <a:ext cx="548640" cy="365760"/>
+              <a:t>General-purpose simulation and data work on CPUs.</a:t>
+            </a:r>
+            <a:endParaRPr lang="en-US" sz="1400" dirty="0"/>
+          </a:p>
+        </p:txBody>
+      </p:sp>
+      <p:sp>
+        <p:nvSpPr>
+          <p:cNvPr id="15" name="Shape 13"/>
+          <p:cNvSpPr/>
+          <p:nvPr/>
+        </p:nvSpPr>
+        <p:spPr>
+          <a:xfrm>
+            <a:off x="8321040" y="2377440"/>
+            <a:ext cx="3611880" cy="3246120"/>
+          </a:xfrm>
+          <a:prstGeom prst="rect">
+            <a:avLst/>
+          </a:prstGeom>
+          <a:solidFill>
+            <a:srgbClr val="EFEDEA"/>
+          </a:solidFill>
+          <a:ln w="12700">
+            <a:solidFill>
+              <a:srgbClr val="EFEDEA"/>
+            </a:solidFill>
+            <a:prstDash val="solid"/>
+          </a:ln>
+        </p:spPr>
+      </p:sp>
+      <p:sp>
+        <p:nvSpPr>
+          <p:cNvPr id="16" name="Text 14"/>
+          <p:cNvSpPr/>
+          <p:nvPr/>
+        </p:nvSpPr>
+        <p:spPr>
+          <a:xfrm>
+            <a:off x="8549640" y="2560320"/>
+            <a:ext cx="3154680" cy="457200"/>
           </a:xfrm>
           <a:prstGeom prst="rect">
             <a:avLst/>
@@ -3554,19 +3885,192 @@
           <a:bodyPr wrap="square" lIns="0" tIns="0" rIns="0" bIns="0" rtlCol="0" anchor="ctr"/>
           <a:lstStyle/>
           <a:p>
-            <a:pPr algn="r" indent="0" marL="0">
-              <a:buNone/>
-            </a:pPr>
-            <a:r>
-              <a:rPr lang="en-US" sz="1200" dirty="0">
-                <a:solidFill>
-                  <a:srgbClr val="6E6E70"/>
+            <a:pPr indent="0" marL="0">
+              <a:buNone/>
+            </a:pPr>
+            <a:r>
+              <a:rPr lang="en-US" sz="2200" b="1" dirty="0">
+                <a:solidFill>
+                  <a:srgbClr val="840028"/>
                 </a:solidFill>
                 <a:latin typeface="Arial" pitchFamily="34" charset="0"/>
                 <a:ea typeface="Arial" pitchFamily="34" charset="-122"/>
                 <a:cs typeface="Arial" pitchFamily="34" charset="-120"/>
               </a:rPr>
-              <a:t>12</a:t>
+              <a:t>Vista</a:t>
+            </a:r>
+            <a:endParaRPr lang="en-US" sz="2200" dirty="0"/>
+          </a:p>
+        </p:txBody>
+      </p:sp>
+      <p:sp>
+        <p:nvSpPr>
+          <p:cNvPr id="17" name="Text 15"/>
+          <p:cNvSpPr/>
+          <p:nvPr/>
+        </p:nvSpPr>
+        <p:spPr>
+          <a:xfrm>
+            <a:off x="8549640" y="3127248"/>
+            <a:ext cx="3154680" cy="868680"/>
+          </a:xfrm>
+          <a:prstGeom prst="rect">
+            <a:avLst/>
+          </a:prstGeom>
+          <a:noFill/>
+          <a:ln/>
+        </p:spPr>
+        <p:txBody>
+          <a:bodyPr wrap="square" lIns="0" tIns="0" rIns="0" bIns="0" rtlCol="0" anchor="t"/>
+          <a:lstStyle/>
+          <a:p>
+            <a:pPr indent="0" marL="0">
+              <a:buNone/>
+            </a:pPr>
+            <a:r>
+              <a:rPr lang="en-US" sz="1450" dirty="0">
+                <a:solidFill>
+                  <a:srgbClr val="1A1A1A"/>
+                </a:solidFill>
+                <a:latin typeface="Calibri" pitchFamily="34" charset="0"/>
+                <a:ea typeface="Calibri" pitchFamily="34" charset="-122"/>
+                <a:cs typeface="Calibri" pitchFamily="34" charset="-120"/>
+              </a:rPr>
+              <a:t>600 GPU nodes (Grace Hopper)</a:t>
+            </a:r>
+            <a:endParaRPr lang="en-US" sz="1450" dirty="0"/>
+          </a:p>
+          <a:p>
+            <a:pPr indent="0" marL="0">
+              <a:buNone/>
+            </a:pPr>
+            <a:r>
+              <a:rPr lang="en-US" sz="1450" dirty="0">
+                <a:solidFill>
+                  <a:srgbClr val="1A1A1A"/>
+                </a:solidFill>
+                <a:latin typeface="Calibri" pitchFamily="34" charset="0"/>
+                <a:ea typeface="Calibri" pitchFamily="34" charset="-122"/>
+                <a:cs typeface="Calibri" pitchFamily="34" charset="-120"/>
+              </a:rPr>
+              <a:t>+ 256 CPU nodes</a:t>
+            </a:r>
+            <a:endParaRPr lang="en-US" sz="1450" dirty="0"/>
+          </a:p>
+        </p:txBody>
+      </p:sp>
+      <p:sp>
+        <p:nvSpPr>
+          <p:cNvPr id="18" name="Text 16"/>
+          <p:cNvSpPr/>
+          <p:nvPr/>
+        </p:nvSpPr>
+        <p:spPr>
+          <a:xfrm>
+            <a:off x="8549640" y="4114800"/>
+            <a:ext cx="3154680" cy="274320"/>
+          </a:xfrm>
+          <a:prstGeom prst="rect">
+            <a:avLst/>
+          </a:prstGeom>
+          <a:noFill/>
+          <a:ln/>
+        </p:spPr>
+        <p:txBody>
+          <a:bodyPr wrap="square" lIns="0" tIns="0" rIns="0" bIns="0" rtlCol="0" anchor="ctr"/>
+          <a:lstStyle/>
+          <a:p>
+            <a:pPr indent="0" marL="0">
+              <a:buNone/>
+            </a:pPr>
+            <a:r>
+              <a:rPr lang="en-US" sz="1200" b="1" spc="200" kern="0" dirty="0">
+                <a:solidFill>
+                  <a:srgbClr val="840028"/>
+                </a:solidFill>
+                <a:latin typeface="Arial" pitchFamily="34" charset="0"/>
+                <a:ea typeface="Arial" pitchFamily="34" charset="-122"/>
+                <a:cs typeface="Arial" pitchFamily="34" charset="-120"/>
+              </a:rPr>
+              <a:t>BEST FOR</a:t>
+            </a:r>
+            <a:endParaRPr lang="en-US" sz="1200" dirty="0"/>
+          </a:p>
+        </p:txBody>
+      </p:sp>
+      <p:sp>
+        <p:nvSpPr>
+          <p:cNvPr id="19" name="Text 17"/>
+          <p:cNvSpPr/>
+          <p:nvPr/>
+        </p:nvSpPr>
+        <p:spPr>
+          <a:xfrm>
+            <a:off x="8549640" y="4407408"/>
+            <a:ext cx="3154680" cy="1051560"/>
+          </a:xfrm>
+          <a:prstGeom prst="rect">
+            <a:avLst/>
+          </a:prstGeom>
+          <a:noFill/>
+          <a:ln/>
+        </p:spPr>
+        <p:txBody>
+          <a:bodyPr wrap="square" lIns="0" tIns="0" rIns="0" bIns="0" rtlCol="0" anchor="t"/>
+          <a:lstStyle/>
+          <a:p>
+            <a:pPr indent="0" marL="0">
+              <a:buNone/>
+            </a:pPr>
+            <a:r>
+              <a:rPr lang="en-US" sz="1400" dirty="0">
+                <a:solidFill>
+                  <a:srgbClr val="1A1A1A"/>
+                </a:solidFill>
+                <a:latin typeface="Calibri" pitchFamily="34" charset="0"/>
+                <a:ea typeface="Calibri" pitchFamily="34" charset="-122"/>
+                <a:cs typeface="Calibri" pitchFamily="34" charset="-120"/>
+              </a:rPr>
+              <a:t>AI, machine learning, and anything that needs GPUs.</a:t>
+            </a:r>
+            <a:endParaRPr lang="en-US" sz="1400" dirty="0"/>
+          </a:p>
+        </p:txBody>
+      </p:sp>
+      <p:sp>
+        <p:nvSpPr>
+          <p:cNvPr id="20" name="Text 18"/>
+          <p:cNvSpPr/>
+          <p:nvPr/>
+        </p:nvSpPr>
+        <p:spPr>
+          <a:xfrm>
+            <a:off x="11185855" y="6217920"/>
+            <a:ext cx="548640" cy="365760"/>
+          </a:xfrm>
+          <a:prstGeom prst="rect">
+            <a:avLst/>
+          </a:prstGeom>
+          <a:noFill/>
+          <a:ln/>
+        </p:spPr>
+        <p:txBody>
+          <a:bodyPr wrap="square" lIns="0" tIns="0" rIns="0" bIns="0" rtlCol="0" anchor="ctr"/>
+          <a:lstStyle/>
+          <a:p>
+            <a:pPr algn="r" indent="0" marL="0">
+              <a:buNone/>
+            </a:pPr>
+            <a:r>
+              <a:rPr lang="en-US" sz="1200" dirty="0">
+                <a:solidFill>
+                  <a:srgbClr val="6E6E70"/>
+                </a:solidFill>
+                <a:latin typeface="Arial" pitchFamily="34" charset="0"/>
+                <a:ea typeface="Arial" pitchFamily="34" charset="-122"/>
+                <a:cs typeface="Arial" pitchFamily="34" charset="-120"/>
+              </a:rPr>
+              <a:t>13</a:t>
             </a:r>
             <a:endParaRPr lang="en-US" sz="1200" dirty="0"/>
           </a:p>
@@ -3580,9 +4084,9 @@
 </p:sld>
 </file>
 
-<file path=ppt/slides/slide13.xml><?xml version="1.0" encoding="utf-8"?>
+<file path=ppt/slides/slide14.xml><?xml version="1.0" encoding="utf-8"?>
 <p:sld xmlns:a="http://schemas.openxmlformats.org/drawingml/2006/main" xmlns:r="http://schemas.openxmlformats.org/officeDocument/2006/relationships" xmlns:p="http://schemas.openxmlformats.org/presentationml/2006/main">
-  <p:cSld name="Slide 13">
+  <p:cSld name="Slide 14">
     <p:bg>
       <p:bgPr>
         <a:solidFill>
@@ -3634,8 +4138,8 @@
         </p:nvSpPr>
         <p:spPr>
           <a:xfrm>
-            <a:off x="640080" y="2011680"/>
-            <a:ext cx="10972800" cy="1645920"/>
+            <a:off x="640080" y="2194560"/>
+            <a:ext cx="10972800" cy="1463040"/>
           </a:xfrm>
           <a:prstGeom prst="rect">
             <a:avLst/>
@@ -3662,7 +4166,7 @@
                 <a:ea typeface="Arial" pitchFamily="34" charset="-122"/>
                 <a:cs typeface="Arial" pitchFamily="34" charset="-120"/>
               </a:rPr>
-              <a:t>Let's get you on the supercomputer.</a:t>
+              <a:t>You're a supercomputer user now.</a:t>
             </a:r>
             <a:endParaRPr lang="en-US" sz="4400" dirty="0"/>
           </a:p>
@@ -3676,8 +4180,8 @@
         </p:nvSpPr>
         <p:spPr>
           <a:xfrm>
-            <a:off x="640080" y="3749040"/>
-            <a:ext cx="10515600" cy="1188720"/>
+            <a:off x="640080" y="3840480"/>
+            <a:ext cx="10515600" cy="914400"/>
           </a:xfrm>
           <a:prstGeom prst="rect">
             <a:avLst/>
@@ -3701,7 +4205,7 @@
                 <a:ea typeface="Calibri" pitchFamily="34" charset="-122"/>
                 <a:cs typeface="Calibri" pitchFamily="34" charset="-120"/>
               </a:rPr>
-              <a:t>What you're about to do, running code across many cores on Frontera, is the same kind of work computational scientists do. You belong in that room.</a:t>
+              <a:t>Frontera today. Stampede3 and Vista whenever your work is ready for them.</a:t>
             </a:r>
             <a:endParaRPr lang="en-US" sz="2000" dirty="0"/>
           </a:p>
@@ -3740,7 +4244,7 @@
                 <a:ea typeface="Calibri" pitchFamily="34" charset="-122"/>
                 <a:cs typeface="Calibri" pitchFamily="34" charset="-120"/>
               </a:rPr>
-              <a:t>Setup, notebook, and slides:  ashleyscruse.github.io/pfx-hpc</a:t>
+              <a:t>Everything from today:  ashleyscruse.github.io/pfx-hpc</a:t>
             </a:r>
             <a:endParaRPr lang="en-US" sz="1500" dirty="0"/>
           </a:p>
@@ -7912,7 +8416,7 @@
                 <a:ea typeface="Calibri" pitchFamily="34" charset="-122"/>
                 <a:cs typeface="Calibri" pitchFamily="34" charset="-120"/>
               </a:rPr>
-              <a:t>Nodes set aside in advance. We're using one today: Morehouse.</a:t>
+              <a:t>Nodes set aside in advance. We're using a reservation today.</a:t>
             </a:r>
             <a:endParaRPr lang="en-US" sz="1350" dirty="0"/>
           </a:p>
@@ -8054,7 +8558,7 @@
                 <a:ea typeface="Calibri" pitchFamily="34" charset="-122"/>
                 <a:cs typeface="Calibri" pitchFamily="34" charset="-120"/>
               </a:rPr>
-              <a:t>A job = “run this program, on this many nodes, for this long.”  Today, TAP used our reservation to get you a node right away.</a:t>
+              <a:t>A job = “run this program, on this many nodes, for this long.”  We have a reservation today, so we'll get nodes right away, no waiting in the queue.</a:t>
             </a:r>
             <a:endParaRPr lang="en-US" sz="1500" dirty="0"/>
           </a:p>
@@ -9093,8 +9597,8 @@
         </p:nvSpPr>
         <p:spPr>
           <a:xfrm>
-            <a:off x="5669280" y="2103120"/>
-            <a:ext cx="5486400" cy="365760"/>
+            <a:off x="5495544" y="2103120"/>
+            <a:ext cx="3931920" cy="365760"/>
           </a:xfrm>
           <a:prstGeom prst="rect">
             <a:avLst/>
@@ -9732,8 +10236,8 @@
         </p:nvSpPr>
         <p:spPr>
           <a:xfrm>
-            <a:off x="5669280" y="4800600"/>
-            <a:ext cx="5486400" cy="548640"/>
+            <a:off x="5495544" y="4800600"/>
+            <a:ext cx="3931920" cy="548640"/>
           </a:xfrm>
           <a:prstGeom prst="rect">
             <a:avLst/>
@@ -10285,17 +10789,17 @@
               <a:buNone/>
             </a:pPr>
             <a:r>
-              <a:rPr lang="en-US" sz="2400" b="1" dirty="0">
-                <a:solidFill>
-                  <a:srgbClr val="840028"/>
-                </a:solidFill>
-                <a:latin typeface="Courier New" pitchFamily="34" charset="0"/>
-                <a:ea typeface="Courier New" pitchFamily="34" charset="-122"/>
-                <a:cs typeface="Courier New" pitchFamily="34" charset="-120"/>
-              </a:rPr>
-              <a:t>print("Hello, Frontera")</a:t>
-            </a:r>
-            <a:endParaRPr lang="en-US" sz="2400" dirty="0"/>
+              <a:rPr lang="en-US" sz="1800" i="1" dirty="0">
+                <a:solidFill>
+                  <a:srgbClr val="6E6E70"/>
+                </a:solidFill>
+                <a:latin typeface="Calibri" pitchFamily="34" charset="0"/>
+                <a:ea typeface="Calibri" pitchFamily="34" charset="-122"/>
+                <a:cs typeface="Calibri" pitchFamily="34" charset="-120"/>
+              </a:rPr>
+              <a:t>The same Python you could learn on a laptop is what runs on Frontera.</a:t>
+            </a:r>
+            <a:endParaRPr lang="en-US" sz="1800" dirty="0"/>
           </a:p>
         </p:txBody>
       </p:sp>

</xml_diff>

<commit_message>
Reframe notebook as exploration, drop Python basics
Notebook:
- Remove the full Python-basics section and the end coding challenge.
- Replace with one short 'Python is Python, anywhere' cell (same language on
  laptop and Frontera) that bridges to the scale demos.
- Reframe intro and wrap-up toward exploring how Python works with a
  supercomputer. No timeline.

Deck: add per-node core counts and totals to the Frontera, Stampede3, and
Vista system cards.
</commit_message>
<xml_diff>
--- a/slides/pfx-hpc-slides.pptx
+++ b/slides/pfx-hpc-slides.pptx
@@ -3561,6 +3561,23 @@
             </a:r>
             <a:endParaRPr lang="en-US" sz="1450" dirty="0"/>
           </a:p>
+          <a:p>
+            <a:pPr indent="0" marL="0">
+              <a:buNone/>
+            </a:pPr>
+            <a:r>
+              <a:rPr lang="en-US" sz="1450" dirty="0">
+                <a:solidFill>
+                  <a:srgbClr val="1A1A1A"/>
+                </a:solidFill>
+                <a:latin typeface="Calibri" pitchFamily="34" charset="0"/>
+                <a:ea typeface="Calibri" pitchFamily="34" charset="-122"/>
+                <a:cs typeface="Calibri" pitchFamily="34" charset="-120"/>
+              </a:rPr>
+              <a:t>(468,608 cores)</a:t>
+            </a:r>
+            <a:endParaRPr lang="en-US" sz="1450" dirty="0"/>
+          </a:p>
         </p:txBody>
       </p:sp>
       <p:sp>
@@ -3755,7 +3772,24 @@
                 <a:ea typeface="Calibri" pitchFamily="34" charset="-122"/>
                 <a:cs typeface="Calibri" pitchFamily="34" charset="-120"/>
               </a:rPr>
-              <a:t>Intel CPUs + some GPUs</a:t>
+              <a:t>48–112 cores per node</a:t>
+            </a:r>
+            <a:endParaRPr lang="en-US" sz="1450" dirty="0"/>
+          </a:p>
+          <a:p>
+            <a:pPr indent="0" marL="0">
+              <a:buNone/>
+            </a:pPr>
+            <a:r>
+              <a:rPr lang="en-US" sz="1450" dirty="0">
+                <a:solidFill>
+                  <a:srgbClr val="1A1A1A"/>
+                </a:solidFill>
+                <a:latin typeface="Calibri" pitchFamily="34" charset="0"/>
+                <a:ea typeface="Calibri" pitchFamily="34" charset="-122"/>
+                <a:cs typeface="Calibri" pitchFamily="34" charset="-120"/>
+              </a:rPr>
+              <a:t>(~100,000+ cores)</a:t>
             </a:r>
             <a:endParaRPr lang="en-US" sz="1450" dirty="0"/>
           </a:p>
@@ -3936,7 +3970,7 @@
                 <a:ea typeface="Calibri" pitchFamily="34" charset="-122"/>
                 <a:cs typeface="Calibri" pitchFamily="34" charset="-120"/>
               </a:rPr>
-              <a:t>600 GPU nodes (Grace Hopper)</a:t>
+              <a:t>600 GPU nodes: 72 cores + 1 GPU</a:t>
             </a:r>
             <a:endParaRPr lang="en-US" sz="1450" dirty="0"/>
           </a:p>
@@ -3953,7 +3987,24 @@
                 <a:ea typeface="Calibri" pitchFamily="34" charset="-122"/>
                 <a:cs typeface="Calibri" pitchFamily="34" charset="-120"/>
               </a:rPr>
-              <a:t>+ 256 CPU nodes</a:t>
+              <a:t>256 CPU nodes: 144 cores</a:t>
+            </a:r>
+            <a:endParaRPr lang="en-US" sz="1450" dirty="0"/>
+          </a:p>
+          <a:p>
+            <a:pPr indent="0" marL="0">
+              <a:buNone/>
+            </a:pPr>
+            <a:r>
+              <a:rPr lang="en-US" sz="1450" dirty="0">
+                <a:solidFill>
+                  <a:srgbClr val="1A1A1A"/>
+                </a:solidFill>
+                <a:latin typeface="Calibri" pitchFamily="34" charset="0"/>
+                <a:ea typeface="Calibri" pitchFamily="34" charset="-122"/>
+                <a:cs typeface="Calibri" pitchFamily="34" charset="-120"/>
+              </a:rPr>
+              <a:t>(~80,000 cores + 600 GPUs)</a:t>
             </a:r>
             <a:endParaRPr lang="en-US" sz="1450" dirty="0"/>
           </a:p>

</xml_diff>